<commit_message>
Pushing the new powerpoints
</commit_message>
<xml_diff>
--- a/host/Splunk/Training Cell - Conversion course - Splunk.pptx
+++ b/host/Splunk/Training Cell - Conversion course - Splunk.pptx
@@ -5,21 +5,20 @@
     <p:sldMasterId id="2147483648" r:id="rId1"/>
   </p:sldMasterIdLst>
   <p:notesMasterIdLst>
-    <p:notesMasterId r:id="rId14"/>
+    <p:notesMasterId r:id="rId13"/>
   </p:notesMasterIdLst>
   <p:sldIdLst>
     <p:sldId id="256" r:id="rId2"/>
     <p:sldId id="257" r:id="rId3"/>
     <p:sldId id="258" r:id="rId4"/>
-    <p:sldId id="269" r:id="rId5"/>
-    <p:sldId id="259" r:id="rId6"/>
-    <p:sldId id="270" r:id="rId7"/>
-    <p:sldId id="272" r:id="rId8"/>
-    <p:sldId id="260" r:id="rId9"/>
-    <p:sldId id="275" r:id="rId10"/>
-    <p:sldId id="277" r:id="rId11"/>
-    <p:sldId id="279" r:id="rId12"/>
-    <p:sldId id="261" r:id="rId13"/>
+    <p:sldId id="259" r:id="rId5"/>
+    <p:sldId id="270" r:id="rId6"/>
+    <p:sldId id="272" r:id="rId7"/>
+    <p:sldId id="260" r:id="rId8"/>
+    <p:sldId id="275" r:id="rId9"/>
+    <p:sldId id="277" r:id="rId10"/>
+    <p:sldId id="279" r:id="rId11"/>
+    <p:sldId id="261" r:id="rId12"/>
   </p:sldIdLst>
   <p:sldSz cx="12192000" cy="6858000"/>
   <p:notesSz cx="6858000" cy="9144000"/>
@@ -208,7 +207,7 @@
           <a:p>
             <a:fld id="{6D908D67-9536-4DD9-AEBE-83236953B92D}" type="datetimeFigureOut">
               <a:rPr lang="en-AU" smtClean="0"/>
-              <a:t>13/04/2026</a:t>
+              <a:t>15/04/2026</a:t>
             </a:fld>
             <a:endParaRPr lang="en-AU"/>
           </a:p>
@@ -522,17 +521,32 @@
           <a:p>
             <a:r>
               <a:rPr lang="en-US" dirty="0"/>
-              <a:t>Teacher notes:</a:t>
-            </a:r>
-          </a:p>
-          <a:p>
+              <a:t>Teacher Notes:</a:t>
+            </a:r>
+          </a:p>
+          <a:p>
+            <a:pPr marL="0" indent="0">
+              <a:buNone/>
+            </a:pPr>
             <a:endParaRPr lang="en-US" dirty="0"/>
           </a:p>
           <a:p>
             <a:r>
               <a:rPr lang="en-US" dirty="0"/>
-              <a:t>An index in Splunk is like a giant filing cabinet where all your data is stored, organized, and made searchable. It’s a way to categorize and organize your data so that Splunk can quickly find and retrieve it when you need it.</a:t>
-            </a:r>
+              <a:t>Splunk is widely used as a SIEM solution (Splunk Enterprise Security) to monitor security events, detect threats, and support incident response</a:t>
+            </a:r>
+          </a:p>
+          <a:p>
+            <a:endParaRPr lang="en-US" dirty="0"/>
+          </a:p>
+          <a:p>
+            <a:r>
+              <a:rPr lang="en-US" dirty="0"/>
+              <a:t>Splunk provides dashboards, alerts, and reports so teams can visualize activity and spot issues in real time or from a incident response angle </a:t>
+            </a:r>
+            <a:endParaRPr lang="en-AU" dirty="0"/>
+          </a:p>
+          <a:p>
             <a:endParaRPr lang="en-AU" dirty="0"/>
           </a:p>
         </p:txBody>
@@ -554,7 +568,7 @@
           <a:p>
             <a:fld id="{62F461C2-7142-42A3-A2AC-57CDC5960F55}" type="slidenum">
               <a:rPr lang="en-AU" smtClean="0"/>
-              <a:t>3</a:t>
+              <a:t>2</a:t>
             </a:fld>
             <a:endParaRPr lang="en-AU"/>
           </a:p>
@@ -563,7 +577,7 @@
     </p:spTree>
     <p:extLst>
       <p:ext uri="{BB962C8B-B14F-4D97-AF65-F5344CB8AC3E}">
-        <p14:creationId xmlns:p14="http://schemas.microsoft.com/office/powerpoint/2010/main" val="3161803539"/>
+        <p14:creationId xmlns:p14="http://schemas.microsoft.com/office/powerpoint/2010/main" val="549613953"/>
       </p:ext>
     </p:extLst>
   </p:cSld>
@@ -617,85 +631,20 @@
           <a:bodyPr/>
           <a:lstStyle/>
           <a:p>
-            <a:pPr marL="0" marR="0" lvl="0" indent="0" algn="l" defTabSz="914400" rtl="0" eaLnBrk="1" fontAlgn="auto" latinLnBrk="0" hangingPunct="1">
-              <a:lnSpc>
-                <a:spcPct val="100000"/>
-              </a:lnSpc>
-              <a:spcBef>
-                <a:spcPts val="0"/>
-              </a:spcBef>
-              <a:spcAft>
-                <a:spcPts val="0"/>
-              </a:spcAft>
-              <a:buClrTx/>
-              <a:buSzTx/>
-              <a:buFontTx/>
-              <a:buNone/>
-              <a:tabLst/>
-              <a:defRPr/>
-            </a:pPr>
-            <a:r>
-              <a:rPr lang="en-AU" dirty="0"/>
-              <a:t>Teacher Notes:</a:t>
-            </a:r>
-          </a:p>
-          <a:p>
-            <a:pPr marL="0" marR="0" lvl="0" indent="0" algn="l" defTabSz="914400" rtl="0" eaLnBrk="1" fontAlgn="auto" latinLnBrk="0" hangingPunct="1">
-              <a:lnSpc>
-                <a:spcPct val="100000"/>
-              </a:lnSpc>
-              <a:spcBef>
-                <a:spcPts val="0"/>
-              </a:spcBef>
-              <a:spcAft>
-                <a:spcPts val="0"/>
-              </a:spcAft>
-              <a:buClrTx/>
-              <a:buSzTx/>
-              <a:buFontTx/>
-              <a:buNone/>
-              <a:tabLst/>
-              <a:defRPr/>
-            </a:pPr>
-            <a:r>
-              <a:rPr lang="en-AU" dirty="0"/>
-              <a:t>- Explore spunk home page</a:t>
-            </a:r>
-          </a:p>
-          <a:p>
-            <a:pPr marL="0" marR="0" lvl="0" indent="0" algn="l" defTabSz="914400" rtl="0" eaLnBrk="1" fontAlgn="auto" latinLnBrk="0" hangingPunct="1">
-              <a:lnSpc>
-                <a:spcPct val="100000"/>
-              </a:lnSpc>
-              <a:spcBef>
-                <a:spcPts val="0"/>
-              </a:spcBef>
-              <a:spcAft>
-                <a:spcPts val="0"/>
-              </a:spcAft>
-              <a:buClrTx/>
-              <a:buSzTx/>
-              <a:buFontTx/>
-              <a:buNone/>
-              <a:tabLst/>
-              <a:defRPr/>
-            </a:pPr>
-            <a:r>
-              <a:rPr lang="en-AU" dirty="0"/>
-              <a:t>(index=* for demo only, use a specified index in production environment)</a:t>
-            </a:r>
-          </a:p>
-          <a:p>
-            <a:r>
-              <a:rPr lang="en-AU" dirty="0"/>
-              <a:t> </a:t>
-            </a:r>
-          </a:p>
-          <a:p>
-            <a:r>
-              <a:rPr lang="en-AU" dirty="0"/>
-              <a:t>Source types are like filters within the index</a:t>
-            </a:r>
+            <a:r>
+              <a:rPr lang="en-US" dirty="0"/>
+              <a:t>Teacher notes:</a:t>
+            </a:r>
+          </a:p>
+          <a:p>
+            <a:endParaRPr lang="en-US" dirty="0"/>
+          </a:p>
+          <a:p>
+            <a:r>
+              <a:rPr lang="en-US" dirty="0"/>
+              <a:t>An index in Splunk is like a giant filing cabinet where all your data is stored, organized, and made searchable. It’s a way to categorize and organize your data so that Splunk can quickly find and retrieve it when you need it.</a:t>
+            </a:r>
+            <a:endParaRPr lang="en-AU" dirty="0"/>
           </a:p>
         </p:txBody>
       </p:sp>
@@ -716,7 +665,7 @@
           <a:p>
             <a:fld id="{62F461C2-7142-42A3-A2AC-57CDC5960F55}" type="slidenum">
               <a:rPr lang="en-AU" smtClean="0"/>
-              <a:t>4</a:t>
+              <a:t>3</a:t>
             </a:fld>
             <a:endParaRPr lang="en-AU"/>
           </a:p>
@@ -725,7 +674,7 @@
     </p:spTree>
     <p:extLst>
       <p:ext uri="{BB962C8B-B14F-4D97-AF65-F5344CB8AC3E}">
-        <p14:creationId xmlns:p14="http://schemas.microsoft.com/office/powerpoint/2010/main" val="479526323"/>
+        <p14:creationId xmlns:p14="http://schemas.microsoft.com/office/powerpoint/2010/main" val="3161803539"/>
       </p:ext>
     </p:extLst>
   </p:cSld>
@@ -817,7 +766,7 @@
           <a:p>
             <a:fld id="{62F461C2-7142-42A3-A2AC-57CDC5960F55}" type="slidenum">
               <a:rPr lang="en-AU" smtClean="0"/>
-              <a:t>5</a:t>
+              <a:t>4</a:t>
             </a:fld>
             <a:endParaRPr lang="en-AU"/>
           </a:p>
@@ -998,7 +947,7 @@
           <a:p>
             <a:fld id="{62F461C2-7142-42A3-A2AC-57CDC5960F55}" type="slidenum">
               <a:rPr lang="en-AU" smtClean="0"/>
-              <a:t>6</a:t>
+              <a:t>5</a:t>
             </a:fld>
             <a:endParaRPr lang="en-AU"/>
           </a:p>
@@ -1095,7 +1044,7 @@
           <a:p>
             <a:fld id="{62F461C2-7142-42A3-A2AC-57CDC5960F55}" type="slidenum">
               <a:rPr lang="en-AU" smtClean="0"/>
-              <a:t>7</a:t>
+              <a:t>6</a:t>
             </a:fld>
             <a:endParaRPr lang="en-AU"/>
           </a:p>
@@ -1192,7 +1141,7 @@
           <a:p>
             <a:fld id="{62F461C2-7142-42A3-A2AC-57CDC5960F55}" type="slidenum">
               <a:rPr lang="en-AU" smtClean="0"/>
-              <a:t>9</a:t>
+              <a:t>8</a:t>
             </a:fld>
             <a:endParaRPr lang="en-AU"/>
           </a:p>
@@ -1266,8 +1215,13 @@
           <a:p>
             <a:r>
               <a:rPr lang="en-US" dirty="0"/>
-              <a:t>Regex is very useful especially to apply fine filtering or refine searches.</a:t>
-            </a:r>
+              <a:t>Regex is very useful especially to apply fine filtering or refine searches and can also be used directly in the command line of </a:t>
+            </a:r>
+            <a:r>
+              <a:rPr lang="en-US" dirty="0" err="1"/>
+              <a:t>splunk</a:t>
+            </a:r>
+            <a:endParaRPr lang="en-US" dirty="0"/>
           </a:p>
           <a:p>
             <a:endParaRPr lang="en-US" dirty="0"/>
@@ -1320,7 +1274,7 @@
           <a:p>
             <a:fld id="{62F461C2-7142-42A3-A2AC-57CDC5960F55}" type="slidenum">
               <a:rPr lang="en-AU" smtClean="0"/>
-              <a:t>10</a:t>
+              <a:t>9</a:t>
             </a:fld>
             <a:endParaRPr lang="en-AU"/>
           </a:p>
@@ -1417,7 +1371,7 @@
           <a:p>
             <a:fld id="{62F461C2-7142-42A3-A2AC-57CDC5960F55}" type="slidenum">
               <a:rPr lang="en-AU" smtClean="0"/>
-              <a:t>11</a:t>
+              <a:t>10</a:t>
             </a:fld>
             <a:endParaRPr lang="en-AU"/>
           </a:p>
@@ -1427,6 +1381,121 @@
     <p:extLst>
       <p:ext uri="{BB962C8B-B14F-4D97-AF65-F5344CB8AC3E}">
         <p14:creationId xmlns:p14="http://schemas.microsoft.com/office/powerpoint/2010/main" val="1891774433"/>
+      </p:ext>
+    </p:extLst>
+  </p:cSld>
+  <p:clrMapOvr>
+    <a:masterClrMapping/>
+  </p:clrMapOvr>
+</p:notes>
+</file>
+
+<file path=ppt/notesSlides/notesSlide9.xml><?xml version="1.0" encoding="utf-8"?>
+<p:notes xmlns:a="http://schemas.openxmlformats.org/drawingml/2006/main" xmlns:r="http://schemas.openxmlformats.org/officeDocument/2006/relationships" xmlns:p="http://schemas.openxmlformats.org/presentationml/2006/main">
+  <p:cSld>
+    <p:spTree>
+      <p:nvGrpSpPr>
+        <p:cNvPr id="1" name=""/>
+        <p:cNvGrpSpPr/>
+        <p:nvPr/>
+      </p:nvGrpSpPr>
+      <p:grpSpPr>
+        <a:xfrm>
+          <a:off x="0" y="0"/>
+          <a:ext cx="0" cy="0"/>
+          <a:chOff x="0" y="0"/>
+          <a:chExt cx="0" cy="0"/>
+        </a:xfrm>
+      </p:grpSpPr>
+      <p:sp>
+        <p:nvSpPr>
+          <p:cNvPr id="2" name="Slide Image Placeholder 1"/>
+          <p:cNvSpPr>
+            <a:spLocks noGrp="1" noRot="1" noChangeAspect="1"/>
+          </p:cNvSpPr>
+          <p:nvPr>
+            <p:ph type="sldImg"/>
+          </p:nvPr>
+        </p:nvSpPr>
+        <p:spPr/>
+      </p:sp>
+      <p:sp>
+        <p:nvSpPr>
+          <p:cNvPr id="3" name="Notes Placeholder 2"/>
+          <p:cNvSpPr>
+            <a:spLocks noGrp="1"/>
+          </p:cNvSpPr>
+          <p:nvPr>
+            <p:ph type="body" idx="1"/>
+          </p:nvPr>
+        </p:nvSpPr>
+        <p:spPr/>
+        <p:txBody>
+          <a:bodyPr/>
+          <a:lstStyle/>
+          <a:p>
+            <a:r>
+              <a:rPr lang="en-US" dirty="0"/>
+              <a:t>Teacher Note: </a:t>
+            </a:r>
+          </a:p>
+          <a:p>
+            <a:endParaRPr lang="en-US" dirty="0"/>
+          </a:p>
+          <a:p>
+            <a:r>
+              <a:rPr lang="en-US" dirty="0"/>
+              <a:t>Baseline dashboards are primarily used to detect what is and isn’t normal.</a:t>
+            </a:r>
+          </a:p>
+          <a:p>
+            <a:endParaRPr lang="en-US" dirty="0"/>
+          </a:p>
+          <a:p>
+            <a:r>
+              <a:rPr lang="en-US" dirty="0"/>
+              <a:t>Drilldown dashboards on important data for further analysis and are very useful in finding artifacts after initial malicious behavior has been detected</a:t>
+            </a:r>
+          </a:p>
+          <a:p>
+            <a:endParaRPr lang="en-US" dirty="0"/>
+          </a:p>
+          <a:p>
+            <a:r>
+              <a:rPr lang="en-US" dirty="0"/>
+              <a:t>Alerts style dashboard are very useful for live or ongoing monitoring.</a:t>
+            </a:r>
+            <a:endParaRPr lang="en-AU" dirty="0"/>
+          </a:p>
+        </p:txBody>
+      </p:sp>
+      <p:sp>
+        <p:nvSpPr>
+          <p:cNvPr id="4" name="Slide Number Placeholder 3"/>
+          <p:cNvSpPr>
+            <a:spLocks noGrp="1"/>
+          </p:cNvSpPr>
+          <p:nvPr>
+            <p:ph type="sldNum" sz="quarter" idx="5"/>
+          </p:nvPr>
+        </p:nvSpPr>
+        <p:spPr/>
+        <p:txBody>
+          <a:bodyPr/>
+          <a:lstStyle/>
+          <a:p>
+            <a:fld id="{62F461C2-7142-42A3-A2AC-57CDC5960F55}" type="slidenum">
+              <a:rPr lang="en-AU" smtClean="0"/>
+              <a:t>11</a:t>
+            </a:fld>
+            <a:endParaRPr lang="en-AU"/>
+          </a:p>
+        </p:txBody>
+      </p:sp>
+    </p:spTree>
+    <p:extLst>
+      <p:ext uri="{BB962C8B-B14F-4D97-AF65-F5344CB8AC3E}">
+        <p14:creationId xmlns:p14="http://schemas.microsoft.com/office/powerpoint/2010/main" val="2402353839"/>
       </p:ext>
     </p:extLst>
   </p:cSld>
@@ -1585,7 +1654,7 @@
           <a:p>
             <a:fld id="{266447FA-567A-498F-ABE1-423C63A16A7D}" type="datetimeFigureOut">
               <a:rPr lang="en-AU" smtClean="0"/>
-              <a:t>13/04/2026</a:t>
+              <a:t>15/04/2026</a:t>
             </a:fld>
             <a:endParaRPr lang="en-AU"/>
           </a:p>
@@ -1785,7 +1854,7 @@
           <a:p>
             <a:fld id="{266447FA-567A-498F-ABE1-423C63A16A7D}" type="datetimeFigureOut">
               <a:rPr lang="en-AU" smtClean="0"/>
-              <a:t>13/04/2026</a:t>
+              <a:t>15/04/2026</a:t>
             </a:fld>
             <a:endParaRPr lang="en-AU"/>
           </a:p>
@@ -1995,7 +2064,7 @@
           <a:p>
             <a:fld id="{266447FA-567A-498F-ABE1-423C63A16A7D}" type="datetimeFigureOut">
               <a:rPr lang="en-AU" smtClean="0"/>
-              <a:t>13/04/2026</a:t>
+              <a:t>15/04/2026</a:t>
             </a:fld>
             <a:endParaRPr lang="en-AU"/>
           </a:p>
@@ -2195,7 +2264,7 @@
           <a:p>
             <a:fld id="{266447FA-567A-498F-ABE1-423C63A16A7D}" type="datetimeFigureOut">
               <a:rPr lang="en-AU" smtClean="0"/>
-              <a:t>13/04/2026</a:t>
+              <a:t>15/04/2026</a:t>
             </a:fld>
             <a:endParaRPr lang="en-AU"/>
           </a:p>
@@ -2471,7 +2540,7 @@
           <a:p>
             <a:fld id="{266447FA-567A-498F-ABE1-423C63A16A7D}" type="datetimeFigureOut">
               <a:rPr lang="en-AU" smtClean="0"/>
-              <a:t>13/04/2026</a:t>
+              <a:t>15/04/2026</a:t>
             </a:fld>
             <a:endParaRPr lang="en-AU"/>
           </a:p>
@@ -2739,7 +2808,7 @@
           <a:p>
             <a:fld id="{266447FA-567A-498F-ABE1-423C63A16A7D}" type="datetimeFigureOut">
               <a:rPr lang="en-AU" smtClean="0"/>
-              <a:t>13/04/2026</a:t>
+              <a:t>15/04/2026</a:t>
             </a:fld>
             <a:endParaRPr lang="en-AU"/>
           </a:p>
@@ -3154,7 +3223,7 @@
           <a:p>
             <a:fld id="{266447FA-567A-498F-ABE1-423C63A16A7D}" type="datetimeFigureOut">
               <a:rPr lang="en-AU" smtClean="0"/>
-              <a:t>13/04/2026</a:t>
+              <a:t>15/04/2026</a:t>
             </a:fld>
             <a:endParaRPr lang="en-AU"/>
           </a:p>
@@ -3296,7 +3365,7 @@
           <a:p>
             <a:fld id="{266447FA-567A-498F-ABE1-423C63A16A7D}" type="datetimeFigureOut">
               <a:rPr lang="en-AU" smtClean="0"/>
-              <a:t>13/04/2026</a:t>
+              <a:t>15/04/2026</a:t>
             </a:fld>
             <a:endParaRPr lang="en-AU"/>
           </a:p>
@@ -3409,7 +3478,7 @@
           <a:p>
             <a:fld id="{266447FA-567A-498F-ABE1-423C63A16A7D}" type="datetimeFigureOut">
               <a:rPr lang="en-AU" smtClean="0"/>
-              <a:t>13/04/2026</a:t>
+              <a:t>15/04/2026</a:t>
             </a:fld>
             <a:endParaRPr lang="en-AU"/>
           </a:p>
@@ -3722,7 +3791,7 @@
           <a:p>
             <a:fld id="{266447FA-567A-498F-ABE1-423C63A16A7D}" type="datetimeFigureOut">
               <a:rPr lang="en-AU" smtClean="0"/>
-              <a:t>13/04/2026</a:t>
+              <a:t>15/04/2026</a:t>
             </a:fld>
             <a:endParaRPr lang="en-AU"/>
           </a:p>
@@ -4011,7 +4080,7 @@
           <a:p>
             <a:fld id="{266447FA-567A-498F-ABE1-423C63A16A7D}" type="datetimeFigureOut">
               <a:rPr lang="en-AU" smtClean="0"/>
-              <a:t>13/04/2026</a:t>
+              <a:t>15/04/2026</a:t>
             </a:fld>
             <a:endParaRPr lang="en-AU"/>
           </a:p>
@@ -4254,7 +4323,7 @@
           <a:p>
             <a:fld id="{266447FA-567A-498F-ABE1-423C63A16A7D}" type="datetimeFigureOut">
               <a:rPr lang="en-AU" smtClean="0"/>
-              <a:t>13/04/2026</a:t>
+              <a:t>15/04/2026</a:t>
             </a:fld>
             <a:endParaRPr lang="en-AU"/>
           </a:p>
@@ -4760,7 +4829,7 @@
           <p:cNvPr id="2" name="Title 1">
             <a:extLst>
               <a:ext uri="{FF2B5EF4-FFF2-40B4-BE49-F238E27FC236}">
-                <a16:creationId xmlns:a16="http://schemas.microsoft.com/office/drawing/2014/main" id="{311C424B-4F60-03EA-57A9-C4318A90D1A8}"/>
+                <a16:creationId xmlns:a16="http://schemas.microsoft.com/office/drawing/2014/main" id="{B881D264-8733-0EF3-C8CC-B7A375921B77}"/>
               </a:ext>
             </a:extLst>
           </p:cNvPr>
@@ -4778,13 +4847,8 @@
           <a:p>
             <a:r>
               <a:rPr lang="en-AU" dirty="0"/>
-              <a:t>Regex in </a:t>
-            </a:r>
-            <a:r>
-              <a:rPr lang="en-AU" dirty="0" err="1"/>
-              <a:t>splunk</a:t>
-            </a:r>
-            <a:endParaRPr lang="en-AU" dirty="0"/>
+              <a:t>Baselining</a:t>
+            </a:r>
           </a:p>
         </p:txBody>
       </p:sp>
@@ -4793,7 +4857,7 @@
           <p:cNvPr id="3" name="Content Placeholder 2">
             <a:extLst>
               <a:ext uri="{FF2B5EF4-FFF2-40B4-BE49-F238E27FC236}">
-                <a16:creationId xmlns:a16="http://schemas.microsoft.com/office/drawing/2014/main" id="{0BE113D1-625D-E148-8A2F-8E8922728008}"/>
+                <a16:creationId xmlns:a16="http://schemas.microsoft.com/office/drawing/2014/main" id="{B92AC551-11EA-69E8-93ED-42FC9CDCC07B}"/>
               </a:ext>
             </a:extLst>
           </p:cNvPr>
@@ -4811,7 +4875,7 @@
           <a:p>
             <a:r>
               <a:rPr lang="en-AU" dirty="0"/>
-              <a:t>If your events has too many strings where it is not able to properly extract values, you can regex events to get better filters. </a:t>
+              <a:t>When you setup in a network the first step you conduct is usually a baseline to determine what is and isn’t normal.</a:t>
             </a:r>
           </a:p>
           <a:p>
@@ -4821,20 +4885,17 @@
             <a:endParaRPr lang="en-AU" dirty="0"/>
           </a:p>
           <a:p>
-            <a:endParaRPr lang="en-AU" dirty="0"/>
-          </a:p>
-          <a:p>
-            <a:pPr marL="0" indent="0">
-              <a:buNone/>
-            </a:pPr>
-            <a:endParaRPr lang="en-AU" dirty="0"/>
+            <a:r>
+              <a:rPr lang="en-AU" dirty="0"/>
+              <a:t>A common was you can do this by making CSV of current data and for future searches you compare the output to the original baseline CSV, any new unique events will flag it. </a:t>
+            </a:r>
           </a:p>
         </p:txBody>
       </p:sp>
     </p:spTree>
     <p:extLst>
       <p:ext uri="{BB962C8B-B14F-4D97-AF65-F5344CB8AC3E}">
-        <p14:creationId xmlns:p14="http://schemas.microsoft.com/office/powerpoint/2010/main" val="2712621605"/>
+        <p14:creationId xmlns:p14="http://schemas.microsoft.com/office/powerpoint/2010/main" val="1719264778"/>
       </p:ext>
     </p:extLst>
   </p:cSld>
@@ -4866,104 +4927,6 @@
           <p:cNvPr id="2" name="Title 1">
             <a:extLst>
               <a:ext uri="{FF2B5EF4-FFF2-40B4-BE49-F238E27FC236}">
-                <a16:creationId xmlns:a16="http://schemas.microsoft.com/office/drawing/2014/main" id="{B881D264-8733-0EF3-C8CC-B7A375921B77}"/>
-              </a:ext>
-            </a:extLst>
-          </p:cNvPr>
-          <p:cNvSpPr>
-            <a:spLocks noGrp="1"/>
-          </p:cNvSpPr>
-          <p:nvPr>
-            <p:ph type="title"/>
-          </p:nvPr>
-        </p:nvSpPr>
-        <p:spPr/>
-        <p:txBody>
-          <a:bodyPr/>
-          <a:lstStyle/>
-          <a:p>
-            <a:r>
-              <a:rPr lang="en-AU" dirty="0"/>
-              <a:t>Baselining</a:t>
-            </a:r>
-          </a:p>
-        </p:txBody>
-      </p:sp>
-      <p:sp>
-        <p:nvSpPr>
-          <p:cNvPr id="3" name="Content Placeholder 2">
-            <a:extLst>
-              <a:ext uri="{FF2B5EF4-FFF2-40B4-BE49-F238E27FC236}">
-                <a16:creationId xmlns:a16="http://schemas.microsoft.com/office/drawing/2014/main" id="{B92AC551-11EA-69E8-93ED-42FC9CDCC07B}"/>
-              </a:ext>
-            </a:extLst>
-          </p:cNvPr>
-          <p:cNvSpPr>
-            <a:spLocks noGrp="1"/>
-          </p:cNvSpPr>
-          <p:nvPr>
-            <p:ph idx="1"/>
-          </p:nvPr>
-        </p:nvSpPr>
-        <p:spPr/>
-        <p:txBody>
-          <a:bodyPr/>
-          <a:lstStyle/>
-          <a:p>
-            <a:r>
-              <a:rPr lang="en-AU" dirty="0"/>
-              <a:t>When you setup in a network the first step you conduct is usually a baseline. </a:t>
-            </a:r>
-          </a:p>
-          <a:p>
-            <a:pPr marL="0" indent="0">
-              <a:buNone/>
-            </a:pPr>
-            <a:endParaRPr lang="en-AU" dirty="0"/>
-          </a:p>
-          <a:p>
-            <a:r>
-              <a:rPr lang="en-AU" dirty="0"/>
-              <a:t>You can do this by making CSV and for future searches you compare the output to the CSV any new unique events will flag it. </a:t>
-            </a:r>
-          </a:p>
-        </p:txBody>
-      </p:sp>
-    </p:spTree>
-    <p:extLst>
-      <p:ext uri="{BB962C8B-B14F-4D97-AF65-F5344CB8AC3E}">
-        <p14:creationId xmlns:p14="http://schemas.microsoft.com/office/powerpoint/2010/main" val="1719264778"/>
-      </p:ext>
-    </p:extLst>
-  </p:cSld>
-  <p:clrMapOvr>
-    <a:masterClrMapping/>
-  </p:clrMapOvr>
-</p:sld>
-</file>
-
-<file path=ppt/slides/slide12.xml><?xml version="1.0" encoding="utf-8"?>
-<p:sld xmlns:a="http://schemas.openxmlformats.org/drawingml/2006/main" xmlns:r="http://schemas.openxmlformats.org/officeDocument/2006/relationships" xmlns:p="http://schemas.openxmlformats.org/presentationml/2006/main">
-  <p:cSld>
-    <p:spTree>
-      <p:nvGrpSpPr>
-        <p:cNvPr id="1" name=""/>
-        <p:cNvGrpSpPr/>
-        <p:nvPr/>
-      </p:nvGrpSpPr>
-      <p:grpSpPr>
-        <a:xfrm>
-          <a:off x="0" y="0"/>
-          <a:ext cx="0" cy="0"/>
-          <a:chOff x="0" y="0"/>
-          <a:chExt cx="0" cy="0"/>
-        </a:xfrm>
-      </p:grpSpPr>
-      <p:sp>
-        <p:nvSpPr>
-          <p:cNvPr id="2" name="Title 1">
-            <a:extLst>
-              <a:ext uri="{FF2B5EF4-FFF2-40B4-BE49-F238E27FC236}">
                 <a16:creationId xmlns:a16="http://schemas.microsoft.com/office/drawing/2014/main" id="{8E7A6994-1E0E-48A5-9938-3C665347D46B}"/>
               </a:ext>
             </a:extLst>
@@ -5019,13 +4982,43 @@
           <a:p>
             <a:r>
               <a:rPr lang="en-US" dirty="0"/>
-              <a:t>Dashboards can also be used to help drill down on important data for further analysis and are very useful in creating baselines to help determine what is and isn’t normal on a network.</a:t>
-            </a:r>
-          </a:p>
-          <a:p>
-            <a:pPr marL="0" indent="0">
-              <a:buNone/>
+              <a:t>Three main uses for dashboards in </a:t>
+            </a:r>
+            <a:r>
+              <a:rPr lang="en-US" dirty="0" err="1"/>
+              <a:t>splunk</a:t>
+            </a:r>
+            <a:endParaRPr lang="en-US" dirty="0"/>
+          </a:p>
+          <a:p>
+            <a:pPr>
+              <a:buFontTx/>
+              <a:buChar char="-"/>
             </a:pPr>
+            <a:r>
+              <a:rPr lang="en-US" dirty="0"/>
+              <a:t>Baseline </a:t>
+            </a:r>
+          </a:p>
+          <a:p>
+            <a:pPr>
+              <a:buFontTx/>
+              <a:buChar char="-"/>
+            </a:pPr>
+            <a:r>
+              <a:rPr lang="en-US" dirty="0"/>
+              <a:t>Drilldown </a:t>
+            </a:r>
+          </a:p>
+          <a:p>
+            <a:pPr>
+              <a:buFontTx/>
+              <a:buChar char="-"/>
+            </a:pPr>
+            <a:r>
+              <a:rPr lang="en-US" dirty="0"/>
+              <a:t>Alerts</a:t>
+            </a:r>
             <a:endParaRPr lang="en-AU" dirty="0"/>
           </a:p>
         </p:txBody>
@@ -5118,25 +5111,6 @@
             </a:r>
           </a:p>
           <a:p>
-            <a:pPr marL="0" indent="0">
-              <a:buNone/>
-            </a:pPr>
-            <a:endParaRPr lang="en-US" dirty="0"/>
-          </a:p>
-          <a:p>
-            <a:r>
-              <a:rPr lang="en-US" dirty="0"/>
-              <a:t>It is widely used as a SIEM solution (Splunk Enterprise Security) to monitor security events, detect threats, and support incident response</a:t>
-            </a:r>
-          </a:p>
-          <a:p>
-            <a:endParaRPr lang="en-US" dirty="0"/>
-          </a:p>
-          <a:p>
-            <a:r>
-              <a:rPr lang="en-US" dirty="0"/>
-              <a:t>Splunk provides dashboards, alerts, and reports so teams can visualize activity and spot issues in real time</a:t>
-            </a:r>
             <a:endParaRPr lang="en-AU" dirty="0"/>
           </a:p>
         </p:txBody>
@@ -5286,191 +5260,6 @@
 </file>
 
 <file path=ppt/slides/slide4.xml><?xml version="1.0" encoding="utf-8"?>
-<p:sld xmlns:a="http://schemas.openxmlformats.org/drawingml/2006/main" xmlns:r="http://schemas.openxmlformats.org/officeDocument/2006/relationships" xmlns:p="http://schemas.openxmlformats.org/presentationml/2006/main">
-  <p:cSld>
-    <p:spTree>
-      <p:nvGrpSpPr>
-        <p:cNvPr id="1" name=""/>
-        <p:cNvGrpSpPr/>
-        <p:nvPr/>
-      </p:nvGrpSpPr>
-      <p:grpSpPr>
-        <a:xfrm>
-          <a:off x="0" y="0"/>
-          <a:ext cx="0" cy="0"/>
-          <a:chOff x="0" y="0"/>
-          <a:chExt cx="0" cy="0"/>
-        </a:xfrm>
-      </p:grpSpPr>
-      <p:sp>
-        <p:nvSpPr>
-          <p:cNvPr id="2" name="Title 1">
-            <a:extLst>
-              <a:ext uri="{FF2B5EF4-FFF2-40B4-BE49-F238E27FC236}">
-                <a16:creationId xmlns:a16="http://schemas.microsoft.com/office/drawing/2014/main" id="{411D65AC-0BD4-3378-49AE-B3769605E014}"/>
-              </a:ext>
-            </a:extLst>
-          </p:cNvPr>
-          <p:cNvSpPr>
-            <a:spLocks noGrp="1"/>
-          </p:cNvSpPr>
-          <p:nvPr>
-            <p:ph type="title"/>
-          </p:nvPr>
-        </p:nvSpPr>
-        <p:spPr/>
-        <p:txBody>
-          <a:bodyPr/>
-          <a:lstStyle/>
-          <a:p>
-            <a:r>
-              <a:rPr lang="en-AU" dirty="0"/>
-              <a:t>Demo - </a:t>
-            </a:r>
-            <a:r>
-              <a:rPr lang="en-AU" dirty="0" err="1"/>
-              <a:t>splunk</a:t>
-            </a:r>
-            <a:r>
-              <a:rPr lang="en-AU" dirty="0"/>
-              <a:t> homepage and viewing source types</a:t>
-            </a:r>
-          </a:p>
-        </p:txBody>
-      </p:sp>
-      <p:sp>
-        <p:nvSpPr>
-          <p:cNvPr id="3" name="Content Placeholder 2">
-            <a:extLst>
-              <a:ext uri="{FF2B5EF4-FFF2-40B4-BE49-F238E27FC236}">
-                <a16:creationId xmlns:a16="http://schemas.microsoft.com/office/drawing/2014/main" id="{E3410602-4487-4787-8BFE-3ABFD0A10F66}"/>
-              </a:ext>
-            </a:extLst>
-          </p:cNvPr>
-          <p:cNvSpPr>
-            <a:spLocks noGrp="1"/>
-          </p:cNvSpPr>
-          <p:nvPr>
-            <p:ph idx="1"/>
-          </p:nvPr>
-        </p:nvSpPr>
-        <p:spPr/>
-        <p:txBody>
-          <a:bodyPr/>
-          <a:lstStyle/>
-          <a:p>
-            <a:pPr marL="0" indent="0">
-              <a:buNone/>
-            </a:pPr>
-            <a:r>
-              <a:rPr lang="en-AU" b="1" dirty="0"/>
-              <a:t>Demo</a:t>
-            </a:r>
-          </a:p>
-          <a:p>
-            <a:r>
-              <a:rPr lang="en-AU" dirty="0"/>
-              <a:t>Navigate to </a:t>
-            </a:r>
-            <a:r>
-              <a:rPr lang="en-AU" dirty="0" err="1"/>
-              <a:t>splunk</a:t>
-            </a:r>
-            <a:r>
-              <a:rPr lang="en-AU" dirty="0"/>
-              <a:t> homepage via </a:t>
-            </a:r>
-            <a:r>
-              <a:rPr lang="en-AU" b="1" dirty="0"/>
-              <a:t>Search&amp; Reporting</a:t>
-            </a:r>
-          </a:p>
-          <a:p>
-            <a:endParaRPr lang="en-AU" b="1" dirty="0"/>
-          </a:p>
-          <a:p>
-            <a:endParaRPr lang="en-AU" dirty="0"/>
-          </a:p>
-          <a:p>
-            <a:pPr marL="0" indent="0">
-              <a:buNone/>
-            </a:pPr>
-            <a:r>
-              <a:rPr lang="en-AU" b="1" dirty="0"/>
-              <a:t>Viewing Source Types</a:t>
-            </a:r>
-          </a:p>
-          <a:p>
-            <a:r>
-              <a:rPr lang="en-AU" dirty="0"/>
-              <a:t>To determine source types loaded into </a:t>
-            </a:r>
-            <a:r>
-              <a:rPr lang="en-AU" dirty="0" err="1"/>
-              <a:t>splunk</a:t>
-            </a:r>
-            <a:r>
-              <a:rPr lang="en-AU" dirty="0"/>
-              <a:t> search:</a:t>
-            </a:r>
-          </a:p>
-          <a:p>
-            <a:pPr marL="0" indent="0">
-              <a:buNone/>
-            </a:pPr>
-            <a:endParaRPr lang="en-AU" dirty="0"/>
-          </a:p>
-        </p:txBody>
-      </p:sp>
-      <p:pic>
-        <p:nvPicPr>
-          <p:cNvPr id="4" name="Picture 3">
-            <a:extLst>
-              <a:ext uri="{FF2B5EF4-FFF2-40B4-BE49-F238E27FC236}">
-                <a16:creationId xmlns:a16="http://schemas.microsoft.com/office/drawing/2014/main" id="{10A20294-A1CC-CB45-1124-08B95F8DFD24}"/>
-              </a:ext>
-            </a:extLst>
-          </p:cNvPr>
-          <p:cNvPicPr>
-            <a:picLocks noChangeAspect="1"/>
-          </p:cNvPicPr>
-          <p:nvPr/>
-        </p:nvPicPr>
-        <p:blipFill>
-          <a:blip r:embed="rId3"/>
-          <a:stretch>
-            <a:fillRect/>
-          </a:stretch>
-        </p:blipFill>
-        <p:spPr>
-          <a:xfrm>
-            <a:off x="1266974" y="4876799"/>
-            <a:ext cx="5731510" cy="988060"/>
-          </a:xfrm>
-          <a:prstGeom prst="rect">
-            <a:avLst/>
-          </a:prstGeom>
-          <a:ln w="25400">
-            <a:solidFill>
-              <a:schemeClr val="tx1"/>
-            </a:solidFill>
-          </a:ln>
-        </p:spPr>
-      </p:pic>
-    </p:spTree>
-    <p:extLst>
-      <p:ext uri="{BB962C8B-B14F-4D97-AF65-F5344CB8AC3E}">
-        <p14:creationId xmlns:p14="http://schemas.microsoft.com/office/powerpoint/2010/main" val="1682876296"/>
-      </p:ext>
-    </p:extLst>
-  </p:cSld>
-  <p:clrMapOvr>
-    <a:masterClrMapping/>
-  </p:clrMapOvr>
-</p:sld>
-</file>
-
-<file path=ppt/slides/slide5.xml><?xml version="1.0" encoding="utf-8"?>
 <p:sld xmlns:a="http://schemas.openxmlformats.org/drawingml/2006/main" xmlns:r="http://schemas.openxmlformats.org/officeDocument/2006/relationships" xmlns:p="http://schemas.openxmlformats.org/presentationml/2006/main">
   <p:cSld>
     <p:spTree>
@@ -5608,7 +5397,7 @@
 </p:sld>
 </file>
 
-<file path=ppt/slides/slide6.xml><?xml version="1.0" encoding="utf-8"?>
+<file path=ppt/slides/slide5.xml><?xml version="1.0" encoding="utf-8"?>
 <p:sld xmlns:a="http://schemas.openxmlformats.org/drawingml/2006/main" xmlns:r="http://schemas.openxmlformats.org/officeDocument/2006/relationships" xmlns:p="http://schemas.openxmlformats.org/presentationml/2006/main">
   <p:cSld>
     <p:spTree>
@@ -5840,6 +5629,120 @@
 </p:sld>
 </file>
 
+<file path=ppt/slides/slide6.xml><?xml version="1.0" encoding="utf-8"?>
+<p:sld xmlns:a="http://schemas.openxmlformats.org/drawingml/2006/main" xmlns:r="http://schemas.openxmlformats.org/officeDocument/2006/relationships" xmlns:p="http://schemas.openxmlformats.org/presentationml/2006/main">
+  <p:cSld>
+    <p:spTree>
+      <p:nvGrpSpPr>
+        <p:cNvPr id="1" name=""/>
+        <p:cNvGrpSpPr/>
+        <p:nvPr/>
+      </p:nvGrpSpPr>
+      <p:grpSpPr>
+        <a:xfrm>
+          <a:off x="0" y="0"/>
+          <a:ext cx="0" cy="0"/>
+          <a:chOff x="0" y="0"/>
+          <a:chExt cx="0" cy="0"/>
+        </a:xfrm>
+      </p:grpSpPr>
+      <p:sp>
+        <p:nvSpPr>
+          <p:cNvPr id="2" name="Title 1">
+            <a:extLst>
+              <a:ext uri="{FF2B5EF4-FFF2-40B4-BE49-F238E27FC236}">
+                <a16:creationId xmlns:a16="http://schemas.microsoft.com/office/drawing/2014/main" id="{38099223-8C60-72F1-74F3-EB0D74064A42}"/>
+              </a:ext>
+            </a:extLst>
+          </p:cNvPr>
+          <p:cNvSpPr>
+            <a:spLocks noGrp="1"/>
+          </p:cNvSpPr>
+          <p:nvPr>
+            <p:ph type="title"/>
+          </p:nvPr>
+        </p:nvSpPr>
+        <p:spPr/>
+        <p:txBody>
+          <a:bodyPr/>
+          <a:lstStyle/>
+          <a:p>
+            <a:r>
+              <a:rPr lang="en-US" dirty="0"/>
+              <a:t>Searching in Splunk - </a:t>
+            </a:r>
+            <a:r>
+              <a:rPr lang="en-AU" dirty="0"/>
+              <a:t>Tables</a:t>
+            </a:r>
+          </a:p>
+        </p:txBody>
+      </p:sp>
+      <p:sp>
+        <p:nvSpPr>
+          <p:cNvPr id="3" name="Content Placeholder 2">
+            <a:extLst>
+              <a:ext uri="{FF2B5EF4-FFF2-40B4-BE49-F238E27FC236}">
+                <a16:creationId xmlns:a16="http://schemas.microsoft.com/office/drawing/2014/main" id="{BC815DDB-ED52-D88A-9A32-FC81EB36DFD5}"/>
+              </a:ext>
+            </a:extLst>
+          </p:cNvPr>
+          <p:cNvSpPr>
+            <a:spLocks noGrp="1"/>
+          </p:cNvSpPr>
+          <p:nvPr>
+            <p:ph idx="1"/>
+          </p:nvPr>
+        </p:nvSpPr>
+        <p:spPr/>
+        <p:txBody>
+          <a:bodyPr/>
+          <a:lstStyle/>
+          <a:p>
+            <a:r>
+              <a:rPr lang="en-AU" dirty="0"/>
+              <a:t>Normal source types have too many fields to analyse at once. </a:t>
+            </a:r>
+          </a:p>
+          <a:p>
+            <a:pPr marL="0" indent="0">
+              <a:buNone/>
+            </a:pPr>
+            <a:endParaRPr lang="en-AU" dirty="0"/>
+          </a:p>
+          <a:p>
+            <a:r>
+              <a:rPr lang="en-AU" dirty="0"/>
+              <a:t>With the table function you are able to select which fields you want to view.</a:t>
+            </a:r>
+          </a:p>
+          <a:p>
+            <a:pPr marL="0" indent="0">
+              <a:buNone/>
+            </a:pPr>
+            <a:endParaRPr lang="en-AU" dirty="0"/>
+          </a:p>
+          <a:p>
+            <a:r>
+              <a:rPr lang="en-AU" dirty="0"/>
+              <a:t>Helpful when generating dashboards as you can select only the important fields.</a:t>
+            </a:r>
+          </a:p>
+        </p:txBody>
+      </p:sp>
+    </p:spTree>
+    <p:extLst>
+      <p:ext uri="{BB962C8B-B14F-4D97-AF65-F5344CB8AC3E}">
+        <p14:creationId xmlns:p14="http://schemas.microsoft.com/office/powerpoint/2010/main" val="2372391513"/>
+      </p:ext>
+    </p:extLst>
+  </p:cSld>
+  <p:clrMapOvr>
+    <a:masterClrMapping/>
+  </p:clrMapOvr>
+</p:sld>
+</file>
+
 <file path=ppt/slides/slide7.xml><?xml version="1.0" encoding="utf-8"?>
 <p:sld xmlns:a="http://schemas.openxmlformats.org/drawingml/2006/main" xmlns:r="http://schemas.openxmlformats.org/officeDocument/2006/relationships" xmlns:p="http://schemas.openxmlformats.org/presentationml/2006/main">
   <p:cSld>
@@ -5862,120 +5765,6 @@
           <p:cNvPr id="2" name="Title 1">
             <a:extLst>
               <a:ext uri="{FF2B5EF4-FFF2-40B4-BE49-F238E27FC236}">
-                <a16:creationId xmlns:a16="http://schemas.microsoft.com/office/drawing/2014/main" id="{38099223-8C60-72F1-74F3-EB0D74064A42}"/>
-              </a:ext>
-            </a:extLst>
-          </p:cNvPr>
-          <p:cNvSpPr>
-            <a:spLocks noGrp="1"/>
-          </p:cNvSpPr>
-          <p:nvPr>
-            <p:ph type="title"/>
-          </p:nvPr>
-        </p:nvSpPr>
-        <p:spPr/>
-        <p:txBody>
-          <a:bodyPr/>
-          <a:lstStyle/>
-          <a:p>
-            <a:r>
-              <a:rPr lang="en-US" dirty="0"/>
-              <a:t>Searching in Splunk - </a:t>
-            </a:r>
-            <a:r>
-              <a:rPr lang="en-AU" dirty="0"/>
-              <a:t>Tables</a:t>
-            </a:r>
-          </a:p>
-        </p:txBody>
-      </p:sp>
-      <p:sp>
-        <p:nvSpPr>
-          <p:cNvPr id="3" name="Content Placeholder 2">
-            <a:extLst>
-              <a:ext uri="{FF2B5EF4-FFF2-40B4-BE49-F238E27FC236}">
-                <a16:creationId xmlns:a16="http://schemas.microsoft.com/office/drawing/2014/main" id="{BC815DDB-ED52-D88A-9A32-FC81EB36DFD5}"/>
-              </a:ext>
-            </a:extLst>
-          </p:cNvPr>
-          <p:cNvSpPr>
-            <a:spLocks noGrp="1"/>
-          </p:cNvSpPr>
-          <p:nvPr>
-            <p:ph idx="1"/>
-          </p:nvPr>
-        </p:nvSpPr>
-        <p:spPr/>
-        <p:txBody>
-          <a:bodyPr/>
-          <a:lstStyle/>
-          <a:p>
-            <a:r>
-              <a:rPr lang="en-AU" dirty="0"/>
-              <a:t>Normal source types have too many fields to analyse at once. </a:t>
-            </a:r>
-          </a:p>
-          <a:p>
-            <a:pPr marL="0" indent="0">
-              <a:buNone/>
-            </a:pPr>
-            <a:endParaRPr lang="en-AU" dirty="0"/>
-          </a:p>
-          <a:p>
-            <a:r>
-              <a:rPr lang="en-AU" dirty="0"/>
-              <a:t>With the table function you are able to select which fields you want to view.</a:t>
-            </a:r>
-          </a:p>
-          <a:p>
-            <a:pPr marL="0" indent="0">
-              <a:buNone/>
-            </a:pPr>
-            <a:endParaRPr lang="en-AU" dirty="0"/>
-          </a:p>
-          <a:p>
-            <a:r>
-              <a:rPr lang="en-AU" dirty="0"/>
-              <a:t>Helpful when generating dashboards as you can select only the important fields.</a:t>
-            </a:r>
-          </a:p>
-        </p:txBody>
-      </p:sp>
-    </p:spTree>
-    <p:extLst>
-      <p:ext uri="{BB962C8B-B14F-4D97-AF65-F5344CB8AC3E}">
-        <p14:creationId xmlns:p14="http://schemas.microsoft.com/office/powerpoint/2010/main" val="2372391513"/>
-      </p:ext>
-    </p:extLst>
-  </p:cSld>
-  <p:clrMapOvr>
-    <a:masterClrMapping/>
-  </p:clrMapOvr>
-</p:sld>
-</file>
-
-<file path=ppt/slides/slide8.xml><?xml version="1.0" encoding="utf-8"?>
-<p:sld xmlns:a="http://schemas.openxmlformats.org/drawingml/2006/main" xmlns:r="http://schemas.openxmlformats.org/officeDocument/2006/relationships" xmlns:p="http://schemas.openxmlformats.org/presentationml/2006/main">
-  <p:cSld>
-    <p:spTree>
-      <p:nvGrpSpPr>
-        <p:cNvPr id="1" name=""/>
-        <p:cNvGrpSpPr/>
-        <p:nvPr/>
-      </p:nvGrpSpPr>
-      <p:grpSpPr>
-        <a:xfrm>
-          <a:off x="0" y="0"/>
-          <a:ext cx="0" cy="0"/>
-          <a:chOff x="0" y="0"/>
-          <a:chExt cx="0" cy="0"/>
-        </a:xfrm>
-      </p:grpSpPr>
-      <p:sp>
-        <p:nvSpPr>
-          <p:cNvPr id="2" name="Title 1">
-            <a:extLst>
-              <a:ext uri="{FF2B5EF4-FFF2-40B4-BE49-F238E27FC236}">
                 <a16:creationId xmlns:a16="http://schemas.microsoft.com/office/drawing/2014/main" id="{157AE698-46F7-3E5F-F52A-65B076596BD7}"/>
               </a:ext>
             </a:extLst>
@@ -6079,7 +5868,7 @@
 </p:sld>
 </file>
 
-<file path=ppt/slides/slide9.xml><?xml version="1.0" encoding="utf-8"?>
+<file path=ppt/slides/slide8.xml><?xml version="1.0" encoding="utf-8"?>
 <p:sld xmlns:a="http://schemas.openxmlformats.org/drawingml/2006/main" xmlns:r="http://schemas.openxmlformats.org/officeDocument/2006/relationships" xmlns:p="http://schemas.openxmlformats.org/presentationml/2006/main">
   <p:cSld>
     <p:spTree>
@@ -6197,6 +5986,126 @@
     <p:extLst>
       <p:ext uri="{BB962C8B-B14F-4D97-AF65-F5344CB8AC3E}">
         <p14:creationId xmlns:p14="http://schemas.microsoft.com/office/powerpoint/2010/main" val="3272005510"/>
+      </p:ext>
+    </p:extLst>
+  </p:cSld>
+  <p:clrMapOvr>
+    <a:masterClrMapping/>
+  </p:clrMapOvr>
+</p:sld>
+</file>
+
+<file path=ppt/slides/slide9.xml><?xml version="1.0" encoding="utf-8"?>
+<p:sld xmlns:a="http://schemas.openxmlformats.org/drawingml/2006/main" xmlns:r="http://schemas.openxmlformats.org/officeDocument/2006/relationships" xmlns:p="http://schemas.openxmlformats.org/presentationml/2006/main">
+  <p:cSld>
+    <p:spTree>
+      <p:nvGrpSpPr>
+        <p:cNvPr id="1" name=""/>
+        <p:cNvGrpSpPr/>
+        <p:nvPr/>
+      </p:nvGrpSpPr>
+      <p:grpSpPr>
+        <a:xfrm>
+          <a:off x="0" y="0"/>
+          <a:ext cx="0" cy="0"/>
+          <a:chOff x="0" y="0"/>
+          <a:chExt cx="0" cy="0"/>
+        </a:xfrm>
+      </p:grpSpPr>
+      <p:sp>
+        <p:nvSpPr>
+          <p:cNvPr id="2" name="Title 1">
+            <a:extLst>
+              <a:ext uri="{FF2B5EF4-FFF2-40B4-BE49-F238E27FC236}">
+                <a16:creationId xmlns:a16="http://schemas.microsoft.com/office/drawing/2014/main" id="{311C424B-4F60-03EA-57A9-C4318A90D1A8}"/>
+              </a:ext>
+            </a:extLst>
+          </p:cNvPr>
+          <p:cNvSpPr>
+            <a:spLocks noGrp="1"/>
+          </p:cNvSpPr>
+          <p:nvPr>
+            <p:ph type="title"/>
+          </p:nvPr>
+        </p:nvSpPr>
+        <p:spPr/>
+        <p:txBody>
+          <a:bodyPr/>
+          <a:lstStyle/>
+          <a:p>
+            <a:r>
+              <a:rPr lang="en-AU" dirty="0"/>
+              <a:t>Regex in </a:t>
+            </a:r>
+            <a:r>
+              <a:rPr lang="en-AU" dirty="0" err="1"/>
+              <a:t>splunk</a:t>
+            </a:r>
+            <a:endParaRPr lang="en-AU" dirty="0"/>
+          </a:p>
+        </p:txBody>
+      </p:sp>
+      <p:sp>
+        <p:nvSpPr>
+          <p:cNvPr id="3" name="Content Placeholder 2">
+            <a:extLst>
+              <a:ext uri="{FF2B5EF4-FFF2-40B4-BE49-F238E27FC236}">
+                <a16:creationId xmlns:a16="http://schemas.microsoft.com/office/drawing/2014/main" id="{0BE113D1-625D-E148-8A2F-8E8922728008}"/>
+              </a:ext>
+            </a:extLst>
+          </p:cNvPr>
+          <p:cNvSpPr>
+            <a:spLocks noGrp="1"/>
+          </p:cNvSpPr>
+          <p:nvPr>
+            <p:ph idx="1"/>
+          </p:nvPr>
+        </p:nvSpPr>
+        <p:spPr/>
+        <p:txBody>
+          <a:bodyPr/>
+          <a:lstStyle/>
+          <a:p>
+            <a:pPr marL="0" indent="0">
+              <a:buNone/>
+            </a:pPr>
+            <a:r>
+              <a:rPr lang="en-AU" dirty="0"/>
+              <a:t>Splunk allows you to extract your own fields through the use of regex.</a:t>
+            </a:r>
+          </a:p>
+          <a:p>
+            <a:pPr marL="0" indent="0">
+              <a:buNone/>
+            </a:pPr>
+            <a:r>
+              <a:rPr lang="en-AU" dirty="0"/>
+              <a:t>This can be useful if you want a field to contain specific events </a:t>
+            </a:r>
+            <a:r>
+              <a:rPr lang="en-AU" dirty="0" err="1"/>
+              <a:t>i.e</a:t>
+            </a:r>
+            <a:r>
+              <a:rPr lang="en-AU" dirty="0"/>
+              <a:t> usernames but one doesn’t exist currently. </a:t>
+            </a:r>
+          </a:p>
+          <a:p>
+            <a:endParaRPr lang="en-AU" dirty="0"/>
+          </a:p>
+          <a:p>
+            <a:pPr marL="0" indent="0">
+              <a:buNone/>
+            </a:pPr>
+            <a:endParaRPr lang="en-AU" dirty="0"/>
+          </a:p>
+        </p:txBody>
+      </p:sp>
+    </p:spTree>
+    <p:extLst>
+      <p:ext uri="{BB962C8B-B14F-4D97-AF65-F5344CB8AC3E}">
+        <p14:creationId xmlns:p14="http://schemas.microsoft.com/office/powerpoint/2010/main" val="2712621605"/>
       </p:ext>
     </p:extLst>
   </p:cSld>

</xml_diff>